<commit_message>
Record the job-shaped proposal and raise Monthly to €2,500.
A starting list in a proposal enters as Stage 2b, not Week 0.
The scope of work copies from that proposal when one exists.
</commit_message>
<xml_diff>
--- a/20-studio/sales/ways-to-work-present.pptx
+++ b/20-studio/sales/ways-to-work-present.pptx
@@ -3571,7 +3571,7 @@
                 <a:ea typeface="Georgia" pitchFamily="34" charset="-122"/>
                 <a:cs typeface="Georgia" pitchFamily="34" charset="-120"/>
               </a:rPr>
-              <a:t>€2,200</a:t>
+              <a:t>€2,500</a:t>
             </a:r>
             <a:endParaRPr lang="en-US" sz="3200" dirty="0"/>
           </a:p>
@@ -4706,7 +4706,7 @@
                 <a:ea typeface="Georgia" pitchFamily="34" charset="-122"/>
                 <a:cs typeface="Georgia" pitchFamily="34" charset="-120"/>
               </a:rPr>
-              <a:t>€2,200</a:t>
+              <a:t>€2,500</a:t>
             </a:r>
             <a:endParaRPr lang="en-US" sz="4000" dirty="0"/>
           </a:p>

</xml_diff>

<commit_message>
Move the offer to three amend rounds. Reprint the card and the Ecoplex pack so they match.
</commit_message>
<xml_diff>
--- a/20-studio/sales/ways-to-work-present.pptx
+++ b/20-studio/sales/ways-to-work-present.pptx
@@ -2270,7 +2270,7 @@
                 <a:ea typeface="Calibri" pitchFamily="34" charset="-122"/>
                 <a:cs typeface="Calibri" pitchFamily="34" charset="-120"/>
               </a:rPr>
-              <a:t>One revision round per piece, 48-hour feedback windows</a:t>
+              <a:t>Three revision rounds per piece, 48-hour feedback windows</a:t>
             </a:r>
             <a:endParaRPr lang="en-US" sz="1600" dirty="0"/>
           </a:p>
@@ -4413,7 +4413,7 @@
                 <a:ea typeface="Calibri" pitchFamily="34" charset="-122"/>
                 <a:cs typeface="Calibri" pitchFamily="34" charset="-120"/>
               </a:rPr>
-              <a:t>One revision round per piece</a:t>
+              <a:t>Three revision rounds per piece</a:t>
             </a:r>
             <a:endParaRPr lang="en-US" sz="1600" dirty="0"/>
           </a:p>
@@ -5048,7 +5048,7 @@
                 <a:ea typeface="Calibri" pitchFamily="34" charset="-122"/>
                 <a:cs typeface="Calibri" pitchFamily="34" charset="-120"/>
               </a:rPr>
-              <a:t>One revision round</a:t>
+              <a:t>Three revision rounds</a:t>
             </a:r>
             <a:endParaRPr lang="en-US" sz="1600" dirty="0"/>
           </a:p>
@@ -5617,7 +5617,7 @@
                 <a:ea typeface="Calibri" pitchFamily="34" charset="-122"/>
                 <a:cs typeface="Calibri" pitchFamily="34" charset="-120"/>
               </a:rPr>
-              <a:t>One revision round</a:t>
+              <a:t>Three revision rounds</a:t>
             </a:r>
             <a:endParaRPr lang="en-US" sz="1600" dirty="0"/>
           </a:p>

</xml_diff>